<commit_message>
Update speaker notes to plain English bullets
</commit_message>
<xml_diff>
--- a/presentation/GSE552_Presentation_v2.pptx
+++ b/presentation/GSE552_Presentation_v2.pptx
@@ -507,7 +507,11 @@
           <a:p>
             <a:r>
               <a:rPr lang="en-US" dirty="0"/>
-              <a:t>SAY: "Hi, I'm James Duce. I'm replicating Jones and Marinescu 2022, published in the AEJ Economic Policy. The paper asks whether Alaska's universal cash dividend changes how much people work. The method is the Synthetic Control Method."</a:t>
+              <a:t>• My name is James Duce
+• I'm replicating a 2022 paper by Jones and Marinescu
+• Published in the American Economic Journal: Economic Policy
+• The paper asks one question: does giving everyone free money make them stop working?
+• The method they use is called the Synthetic Control Method</a:t>
             </a:r>
             <a:endParaRPr lang="en-US" dirty="0"/>
           </a:p>
@@ -595,7 +599,12 @@
           <a:p>
             <a:r>
               <a:rPr lang="en-US" dirty="0"/>
-              <a:t>SAY: "Alaska's dividend has been paid to every resident since 1982 — universal, permanent, no work requirement. Theory says people should work less. But the challenge is that everyone got treated simultaneously — no control group, can't do DiD, and Alaska's oil boom confounds any before/after comparison. SCM builds a statistical twin for Alaska from other states that matched its labor market before 1982. Any gap after 1982 is the treatment effect."</a:t>
+              <a:t>• Alaska has paid every resident $1,000–$2,000 per year since 1982 — no strings attached
+• Basic economics says: if you get free money, you'll work less
+• The problem: every single Alaskan got it at the same time, so there's no comparison group inside Alaska
+• We also can't just compare before and after 1982 — Alaska had an oil boom at the same time
+• The fix: Synthetic Control builds a fake version of Alaska from other states that looked just like Alaska before 1982
+• After 1982, we compare real Alaska to this "Synthetic Alaska" — any gap is the effect of the dividend</a:t>
             </a:r>
             <a:endParaRPr lang="en-US" dirty="0"/>
           </a:p>
@@ -683,7 +692,10 @@
           <a:p>
             <a:r>
               <a:rPr lang="en-US" dirty="0"/>
-              <a:t>SAY: "Data is the Current Population Survey, 51 state-year units, 1977 to 2014. I used the authors' pre-processed panel files — no raw data wrangling needed. Four outcomes: employment rate, part-time rate, labor force participation, and hours worked. Alaska's pre-dividend employment rate was 63.9%."</a:t>
+              <a:t>• Data comes from the Current Population Survey — the main U.S. jobs survey
+• Covers all 50 states plus D.C., from 1977 to 2014
+• We look at four things: whether people are employed, working part-time, in the labor force, and how many hours they work
+• Before the dividend started, about 64% of Alaskans were employed — that's our starting point</a:t>
             </a:r>
             <a:endParaRPr lang="en-US" dirty="0"/>
           </a:p>
@@ -771,7 +783,14 @@
           <a:p>
             <a:r>
               <a:rPr lang="en-US" dirty="0"/>
-              <a:t>SAY: "Left is Figure 2 — employment. The lines track tightly before 1982, pre-RMSE 0.0036. After 1982 they stay close — effect +0.013, p = 0.459. No significant employment effect, the headline null result replicates. Right is Figure 3 — part-time. Alaska drifts upward above Synthetic Alaska post-1982. My estimate is +1.2pp vs the paper's +1.8pp. Same direction — significance differs only because I ran ~50 placebos vs the paper's 1,836."</a:t>
+              <a:t>• Left figure: employment rate — Alaska vs Synthetic Alaska from 1977 to 2014
+• Before 1982 the two lines sit right on top of each other — that's a good sign, our fake Alaska is a valid twin
+• After 1982 the lines stay close together — the dividend did NOT change employment
+• Our result: +0.013, p = 0.459 — not statistically significant, matches the paper's null result
+• Right figure: part-time employment rate
+• After 1982 Alaska's line drifts above Synthetic Alaska — people shifted toward part-time work
+• Our result: +0.012, same direction as the paper's +0.018
+• The paper finds this significant; ours isn't — because we ran fewer comparison tests (more on that next slide)</a:t>
             </a:r>
             <a:endParaRPr lang="en-US" dirty="0"/>
           </a:p>
@@ -859,7 +878,17 @@
           <a:p>
             <a:r>
               <a:rPr lang="en-US" dirty="0"/>
-              <a:t>SAY: "Across all four outcomes, none show significant employment reduction — qualitative conclusion matches the paper. The right side explains why: there's a micro income effect of −0.6pp from labor supply, but a macro demand effect of +0.5pp when everyone spends locally. They nearly cancel. The income effect shows up instead as a part-time shift — people cut hours without quitting."</a:t>
+              <a:t>• Table shows all four outcomes — published result vs what we got
+• Every single outcome points in the same direction as the paper
+• None show a significant drop in employment — the main finding replicates
+• Why didn't employment fall? Two forces nearly cancel each other out:
+  — People getting free money work a little less (income effect: −0.6pp)
+  — But everyone spends that money locally, which creates jobs (demand effect: +0.5pp)
+  — The two nearly cancel → net effect on employment is basically zero
+• The income effect shows up instead as people cutting hours — shifting to part-time rather than quitting
+• Why do our p-values differ from the paper? The paper ran 1,836 comparison tests; we ran about 50
+  — Fewer tests = less precision = harder to reach statistical significance
+  — The direction and size of the effects are still very similar</a:t>
             </a:r>
             <a:endParaRPr lang="en-US" dirty="0"/>
           </a:p>
@@ -947,7 +976,11 @@
           <a:p>
             <a:r>
               <a:rPr lang="en-US" dirty="0"/>
-              <a:t>SAY: "Four takeaways. Universal cash doesn't reduce employment — GE demand effects offset the income effect. The income effect shows up in hours, not jobs. For UBI policy, macro effects are smaller than micro models predict. And the SCM lesson: credibility lives in pre-period fit, and p-values depend heavily on placebo pool size. Thanks."</a:t>
+              <a:t>• Giving everyone cash at the same time doesn't kill jobs — the spending creates new ones that offset it
+• The effect shows up in how many hours people work, not whether they work at all
+• For UBI policy: real-world effects on employment are probably much smaller than simple models suggest
+• For the method: the synthetic control only works if your fake version matches the real one closely before treatment — ours did (RMSE 0.0036 is very tight)
+• And p-values in this method depend heavily on how many comparison tests you run — something to keep in mind when reading SCM papers</a:t>
             </a:r>
             <a:endParaRPr lang="en-US" dirty="0"/>
           </a:p>

</xml_diff>